<commit_message>
update project section images
</commit_message>
<xml_diff>
--- a/images/project image reshaper.pptx
+++ b/images/project image reshaper.pptx
@@ -7,10 +7,10 @@
   <p:sldIdLst>
     <p:sldId id="261" r:id="rId2"/>
     <p:sldId id="256" r:id="rId3"/>
-    <p:sldId id="258" r:id="rId4"/>
-    <p:sldId id="259" r:id="rId5"/>
-    <p:sldId id="260" r:id="rId6"/>
-    <p:sldId id="257" r:id="rId7"/>
+    <p:sldId id="262" r:id="rId4"/>
+    <p:sldId id="258" r:id="rId5"/>
+    <p:sldId id="259" r:id="rId6"/>
+    <p:sldId id="260" r:id="rId7"/>
   </p:sldIdLst>
   <p:sldSz cx="12192000" cy="6858000"/>
   <p:notesSz cx="6858000" cy="9144000"/>
@@ -3908,10 +3908,10 @@
       </p:sp>
       <p:pic>
         <p:nvPicPr>
-          <p:cNvPr id="8" name="Picture 7">
-            <a:extLst>
-              <a:ext uri="{FF2B5EF4-FFF2-40B4-BE49-F238E27FC236}">
-                <a16:creationId xmlns:a16="http://schemas.microsoft.com/office/drawing/2014/main" id="{A0C104CD-E16D-D8B9-487F-BADAF0079835}"/>
+          <p:cNvPr id="3" name="Picture 2">
+            <a:extLst>
+              <a:ext uri="{FF2B5EF4-FFF2-40B4-BE49-F238E27FC236}">
+                <a16:creationId xmlns:a16="http://schemas.microsoft.com/office/drawing/2014/main" id="{8D293B88-021D-BF8F-57C2-B94D2475D173}"/>
               </a:ext>
             </a:extLst>
           </p:cNvPr>
@@ -3934,8 +3934,8 @@
         </p:blipFill>
         <p:spPr>
           <a:xfrm>
-            <a:off x="1426442" y="847206"/>
-            <a:ext cx="9339113" cy="5328178"/>
+            <a:off x="1311727" y="736415"/>
+            <a:ext cx="9568543" cy="5385167"/>
           </a:xfrm>
           <a:prstGeom prst="rect">
             <a:avLst/>
@@ -3956,6 +3956,132 @@
 </file>
 
 <file path=ppt/slides/slide3.xml><?xml version="1.0" encoding="utf-8"?>
+<p:sld xmlns:a="http://schemas.openxmlformats.org/drawingml/2006/main" xmlns:r="http://schemas.openxmlformats.org/officeDocument/2006/relationships" xmlns:p="http://schemas.openxmlformats.org/presentationml/2006/main">
+  <p:cSld>
+    <p:spTree>
+      <p:nvGrpSpPr>
+        <p:cNvPr id="1" name="">
+          <a:extLst>
+            <a:ext uri="{FF2B5EF4-FFF2-40B4-BE49-F238E27FC236}">
+              <a16:creationId xmlns:a16="http://schemas.microsoft.com/office/drawing/2014/main" id="{0841939C-6742-C7C5-2F9E-D8A86AC9CC49}"/>
+            </a:ext>
+          </a:extLst>
+        </p:cNvPr>
+        <p:cNvGrpSpPr/>
+        <p:nvPr/>
+      </p:nvGrpSpPr>
+      <p:grpSpPr>
+        <a:xfrm>
+          <a:off x="0" y="0"/>
+          <a:ext cx="0" cy="0"/>
+          <a:chOff x="0" y="0"/>
+          <a:chExt cx="0" cy="0"/>
+        </a:xfrm>
+      </p:grpSpPr>
+      <p:sp>
+        <p:nvSpPr>
+          <p:cNvPr id="6" name="Rectangle 5">
+            <a:extLst>
+              <a:ext uri="{FF2B5EF4-FFF2-40B4-BE49-F238E27FC236}">
+                <a16:creationId xmlns:a16="http://schemas.microsoft.com/office/drawing/2014/main" id="{36F51B5F-FE77-8507-D577-92C0F7AA5397}"/>
+              </a:ext>
+            </a:extLst>
+          </p:cNvPr>
+          <p:cNvSpPr/>
+          <p:nvPr/>
+        </p:nvSpPr>
+        <p:spPr>
+          <a:xfrm>
+            <a:off x="1311728" y="479689"/>
+            <a:ext cx="9568543" cy="5898621"/>
+          </a:xfrm>
+          <a:prstGeom prst="rect">
+            <a:avLst/>
+          </a:prstGeom>
+          <a:solidFill>
+            <a:schemeClr val="bg1"/>
+          </a:solidFill>
+          <a:ln>
+            <a:solidFill>
+              <a:schemeClr val="bg1"/>
+            </a:solidFill>
+          </a:ln>
+        </p:spPr>
+        <p:style>
+          <a:lnRef idx="2">
+            <a:schemeClr val="accent1">
+              <a:shade val="15000"/>
+            </a:schemeClr>
+          </a:lnRef>
+          <a:fillRef idx="1">
+            <a:schemeClr val="accent1"/>
+          </a:fillRef>
+          <a:effectRef idx="0">
+            <a:schemeClr val="accent1"/>
+          </a:effectRef>
+          <a:fontRef idx="minor">
+            <a:schemeClr val="lt1"/>
+          </a:fontRef>
+        </p:style>
+        <p:txBody>
+          <a:bodyPr rtlCol="0" anchor="ctr"/>
+          <a:lstStyle/>
+          <a:p>
+            <a:pPr algn="ctr"/>
+            <a:endParaRPr lang="en-US"/>
+          </a:p>
+        </p:txBody>
+      </p:sp>
+      <p:pic>
+        <p:nvPicPr>
+          <p:cNvPr id="3" name="Picture 2">
+            <a:extLst>
+              <a:ext uri="{FF2B5EF4-FFF2-40B4-BE49-F238E27FC236}">
+                <a16:creationId xmlns:a16="http://schemas.microsoft.com/office/drawing/2014/main" id="{4881CD1F-A642-B1BB-C34A-487EA91F2825}"/>
+              </a:ext>
+            </a:extLst>
+          </p:cNvPr>
+          <p:cNvPicPr>
+            <a:picLocks noChangeAspect="1"/>
+          </p:cNvPicPr>
+          <p:nvPr/>
+        </p:nvPicPr>
+        <p:blipFill>
+          <a:blip r:embed="rId2">
+            <a:extLst>
+              <a:ext uri="{28A0092B-C50C-407E-A947-70E740481C1C}">
+                <a14:useLocalDpi xmlns:a14="http://schemas.microsoft.com/office/drawing/2010/main" val="0"/>
+              </a:ext>
+            </a:extLst>
+          </a:blip>
+          <a:stretch>
+            <a:fillRect/>
+          </a:stretch>
+        </p:blipFill>
+        <p:spPr>
+          <a:xfrm>
+            <a:off x="1386051" y="741866"/>
+            <a:ext cx="9419897" cy="5374267"/>
+          </a:xfrm>
+          <a:prstGeom prst="rect">
+            <a:avLst/>
+          </a:prstGeom>
+        </p:spPr>
+      </p:pic>
+    </p:spTree>
+    <p:extLst>
+      <p:ext uri="{BB962C8B-B14F-4D97-AF65-F5344CB8AC3E}">
+        <p14:creationId xmlns:p14="http://schemas.microsoft.com/office/powerpoint/2010/main" val="3763557548"/>
+      </p:ext>
+    </p:extLst>
+  </p:cSld>
+  <p:clrMapOvr>
+    <a:masterClrMapping/>
+  </p:clrMapOvr>
+</p:sld>
+</file>
+
+<file path=ppt/slides/slide4.xml><?xml version="1.0" encoding="utf-8"?>
 <p:sld xmlns:a="http://schemas.openxmlformats.org/drawingml/2006/main" xmlns:r="http://schemas.openxmlformats.org/officeDocument/2006/relationships" xmlns:p="http://schemas.openxmlformats.org/presentationml/2006/main">
   <p:cSld>
     <p:spTree>
@@ -4034,10 +4160,10 @@
       </p:sp>
       <p:pic>
         <p:nvPicPr>
-          <p:cNvPr id="5" name="Picture 4">
-            <a:extLst>
-              <a:ext uri="{FF2B5EF4-FFF2-40B4-BE49-F238E27FC236}">
-                <a16:creationId xmlns:a16="http://schemas.microsoft.com/office/drawing/2014/main" id="{C8D4342D-0B38-497B-D713-9E8CA8626E18}"/>
+          <p:cNvPr id="3" name="Picture 2">
+            <a:extLst>
+              <a:ext uri="{FF2B5EF4-FFF2-40B4-BE49-F238E27FC236}">
+                <a16:creationId xmlns:a16="http://schemas.microsoft.com/office/drawing/2014/main" id="{BA94F429-31AC-71F0-C975-C1495255BAB9}"/>
               </a:ext>
             </a:extLst>
           </p:cNvPr>
@@ -4054,15 +4180,15 @@
               </a:ext>
             </a:extLst>
           </a:blip>
-          <a:srcRect r="8705"/>
+          <a:srcRect l="753" r="753"/>
           <a:stretch>
             <a:fillRect/>
           </a:stretch>
         </p:blipFill>
         <p:spPr>
           <a:xfrm>
-            <a:off x="1311728" y="479689"/>
-            <a:ext cx="9568543" cy="5898621"/>
+            <a:off x="1311728" y="695210"/>
+            <a:ext cx="9568543" cy="5467579"/>
           </a:xfrm>
           <a:prstGeom prst="rect">
             <a:avLst/>
@@ -4082,7 +4208,7 @@
 </p:sld>
 </file>
 
-<file path=ppt/slides/slide4.xml><?xml version="1.0" encoding="utf-8"?>
+<file path=ppt/slides/slide5.xml><?xml version="1.0" encoding="utf-8"?>
 <p:sld xmlns:a="http://schemas.openxmlformats.org/drawingml/2006/main" xmlns:r="http://schemas.openxmlformats.org/officeDocument/2006/relationships" xmlns:p="http://schemas.openxmlformats.org/presentationml/2006/main">
   <p:cSld>
     <p:spTree>
@@ -4209,7 +4335,7 @@
 </p:sld>
 </file>
 
-<file path=ppt/slides/slide5.xml><?xml version="1.0" encoding="utf-8"?>
+<file path=ppt/slides/slide6.xml><?xml version="1.0" encoding="utf-8"?>
 <p:sld xmlns:a="http://schemas.openxmlformats.org/drawingml/2006/main" xmlns:r="http://schemas.openxmlformats.org/officeDocument/2006/relationships" xmlns:p="http://schemas.openxmlformats.org/presentationml/2006/main">
   <p:cSld>
     <p:spTree>
@@ -4335,72 +4461,6 @@
     <p:extLst>
       <p:ext uri="{BB962C8B-B14F-4D97-AF65-F5344CB8AC3E}">
         <p14:creationId xmlns:p14="http://schemas.microsoft.com/office/powerpoint/2010/main" val="946357920"/>
-      </p:ext>
-    </p:extLst>
-  </p:cSld>
-  <p:clrMapOvr>
-    <a:masterClrMapping/>
-  </p:clrMapOvr>
-</p:sld>
-</file>
-
-<file path=ppt/slides/slide6.xml><?xml version="1.0" encoding="utf-8"?>
-<p:sld xmlns:a="http://schemas.openxmlformats.org/drawingml/2006/main" xmlns:r="http://schemas.openxmlformats.org/officeDocument/2006/relationships" xmlns:p="http://schemas.openxmlformats.org/presentationml/2006/main">
-  <p:cSld>
-    <p:spTree>
-      <p:nvGrpSpPr>
-        <p:cNvPr id="1" name="">
-          <a:extLst>
-            <a:ext uri="{FF2B5EF4-FFF2-40B4-BE49-F238E27FC236}">
-              <a16:creationId xmlns:a16="http://schemas.microsoft.com/office/drawing/2014/main" id="{09A49890-42F0-CDC1-AE44-AA3065DB089F}"/>
-            </a:ext>
-          </a:extLst>
-        </p:cNvPr>
-        <p:cNvGrpSpPr/>
-        <p:nvPr/>
-      </p:nvGrpSpPr>
-      <p:grpSpPr>
-        <a:xfrm>
-          <a:off x="0" y="0"/>
-          <a:ext cx="0" cy="0"/>
-          <a:chOff x="0" y="0"/>
-          <a:chExt cx="0" cy="0"/>
-        </a:xfrm>
-      </p:grpSpPr>
-      <p:pic>
-        <p:nvPicPr>
-          <p:cNvPr id="3" name="Picture 2">
-            <a:extLst>
-              <a:ext uri="{FF2B5EF4-FFF2-40B4-BE49-F238E27FC236}">
-                <a16:creationId xmlns:a16="http://schemas.microsoft.com/office/drawing/2014/main" id="{7B04A890-D734-23B2-5E60-FE9141DDDD2A}"/>
-              </a:ext>
-            </a:extLst>
-          </p:cNvPr>
-          <p:cNvPicPr>
-            <a:picLocks noChangeAspect="1"/>
-          </p:cNvPicPr>
-          <p:nvPr/>
-        </p:nvPicPr>
-        <p:blipFill>
-          <a:blip r:embed="rId2"/>
-          <a:stretch>
-            <a:fillRect/>
-          </a:stretch>
-        </p:blipFill>
-        <p:spPr>
-          <a:xfrm>
-            <a:off x="1301080" y="536191"/>
-            <a:ext cx="9589839" cy="5913633"/>
-          </a:xfrm>
-          <a:prstGeom prst="rect">
-            <a:avLst/>
-          </a:prstGeom>
-        </p:spPr>
-      </p:pic>
-    </p:spTree>
-    <p:extLst>
-      <p:ext uri="{BB962C8B-B14F-4D97-AF65-F5344CB8AC3E}">
-        <p14:creationId xmlns:p14="http://schemas.microsoft.com/office/powerpoint/2010/main" val="626323820"/>
       </p:ext>
     </p:extLst>
   </p:cSld>

</xml_diff>

<commit_message>
changed hero section image
</commit_message>
<xml_diff>
--- a/images/project image reshaper.pptx
+++ b/images/project image reshaper.pptx
@@ -11,6 +11,7 @@
     <p:sldId id="258" r:id="rId5"/>
     <p:sldId id="259" r:id="rId6"/>
     <p:sldId id="260" r:id="rId7"/>
+    <p:sldId id="263" r:id="rId8"/>
   </p:sldIdLst>
   <p:sldSz cx="12192000" cy="6858000"/>
   <p:notesSz cx="6858000" cy="9144000"/>
@@ -4470,6 +4471,304 @@
 </p:sld>
 </file>
 
+<file path=ppt/slides/slide7.xml><?xml version="1.0" encoding="utf-8"?>
+<p:sld xmlns:a="http://schemas.openxmlformats.org/drawingml/2006/main" xmlns:r="http://schemas.openxmlformats.org/officeDocument/2006/relationships" xmlns:p="http://schemas.openxmlformats.org/presentationml/2006/main">
+  <p:cSld>
+    <p:bg>
+      <p:bgPr>
+        <a:solidFill>
+          <a:schemeClr val="bg1"/>
+        </a:solidFill>
+        <a:effectLst/>
+      </p:bgPr>
+    </p:bg>
+    <p:spTree>
+      <p:nvGrpSpPr>
+        <p:cNvPr id="1" name=""/>
+        <p:cNvGrpSpPr/>
+        <p:nvPr/>
+      </p:nvGrpSpPr>
+      <p:grpSpPr>
+        <a:xfrm>
+          <a:off x="0" y="0"/>
+          <a:ext cx="0" cy="0"/>
+          <a:chOff x="0" y="0"/>
+          <a:chExt cx="0" cy="0"/>
+        </a:xfrm>
+      </p:grpSpPr>
+      <p:sp>
+        <p:nvSpPr>
+          <p:cNvPr id="10" name="Rectangle 9">
+            <a:extLst>
+              <a:ext uri="{FF2B5EF4-FFF2-40B4-BE49-F238E27FC236}">
+                <a16:creationId xmlns:a16="http://schemas.microsoft.com/office/drawing/2014/main" id="{42A4FC2C-047E-45A5-965D-8E1E3BF09BC6}"/>
+              </a:ext>
+              <a:ext uri="{C183D7F6-B498-43B3-948B-1728B52AA6E4}">
+                <adec:decorative xmlns:adec="http://schemas.microsoft.com/office/drawing/2017/decorative" val="1"/>
+              </a:ext>
+            </a:extLst>
+          </p:cNvPr>
+          <p:cNvSpPr>
+            <a:spLocks noGrp="1" noRot="1" noChangeAspect="1" noMove="1" noResize="1" noEditPoints="1" noAdjustHandles="1" noChangeArrowheads="1" noChangeShapeType="1" noTextEdit="1"/>
+          </p:cNvSpPr>
+          <p:nvPr>
+            <p:extLst>
+              <p:ext uri="{386F3935-93C4-4BCD-93E2-E3B085C9AB24}">
+                <p16:designElem xmlns:p16="http://schemas.microsoft.com/office/powerpoint/2015/main" val="1"/>
+              </p:ext>
+            </p:extLst>
+          </p:nvPr>
+        </p:nvSpPr>
+        <p:spPr bwMode="white">
+          <a:xfrm>
+            <a:off x="1524" y="0"/>
+            <a:ext cx="12188952" cy="6858000"/>
+          </a:xfrm>
+          <a:prstGeom prst="rect">
+            <a:avLst/>
+          </a:prstGeom>
+          <a:noFill/>
+          <a:ln>
+            <a:noFill/>
+          </a:ln>
+        </p:spPr>
+        <p:style>
+          <a:lnRef idx="2">
+            <a:schemeClr val="accent1">
+              <a:shade val="50000"/>
+            </a:schemeClr>
+          </a:lnRef>
+          <a:fillRef idx="1">
+            <a:schemeClr val="accent1"/>
+          </a:fillRef>
+          <a:effectRef idx="0">
+            <a:schemeClr val="accent1"/>
+          </a:effectRef>
+          <a:fontRef idx="minor">
+            <a:schemeClr val="lt1"/>
+          </a:fontRef>
+        </p:style>
+        <p:txBody>
+          <a:bodyPr rtlCol="0" anchor="ctr"/>
+          <a:lstStyle>
+            <a:defPPr>
+              <a:defRPr lang="en-US"/>
+            </a:defPPr>
+            <a:lvl1pPr marL="0" algn="l" defTabSz="914400" rtl="0" eaLnBrk="1" latinLnBrk="0" hangingPunct="1">
+              <a:defRPr sz="1800" kern="1200">
+                <a:solidFill>
+                  <a:schemeClr val="lt1"/>
+                </a:solidFill>
+                <a:latin typeface="+mn-lt"/>
+                <a:ea typeface="+mn-ea"/>
+                <a:cs typeface="+mn-cs"/>
+              </a:defRPr>
+            </a:lvl1pPr>
+            <a:lvl2pPr marL="457200" algn="l" defTabSz="914400" rtl="0" eaLnBrk="1" latinLnBrk="0" hangingPunct="1">
+              <a:defRPr sz="1800" kern="1200">
+                <a:solidFill>
+                  <a:schemeClr val="lt1"/>
+                </a:solidFill>
+                <a:latin typeface="+mn-lt"/>
+                <a:ea typeface="+mn-ea"/>
+                <a:cs typeface="+mn-cs"/>
+              </a:defRPr>
+            </a:lvl2pPr>
+            <a:lvl3pPr marL="914400" algn="l" defTabSz="914400" rtl="0" eaLnBrk="1" latinLnBrk="0" hangingPunct="1">
+              <a:defRPr sz="1800" kern="1200">
+                <a:solidFill>
+                  <a:schemeClr val="lt1"/>
+                </a:solidFill>
+                <a:latin typeface="+mn-lt"/>
+                <a:ea typeface="+mn-ea"/>
+                <a:cs typeface="+mn-cs"/>
+              </a:defRPr>
+            </a:lvl3pPr>
+            <a:lvl4pPr marL="1371600" algn="l" defTabSz="914400" rtl="0" eaLnBrk="1" latinLnBrk="0" hangingPunct="1">
+              <a:defRPr sz="1800" kern="1200">
+                <a:solidFill>
+                  <a:schemeClr val="lt1"/>
+                </a:solidFill>
+                <a:latin typeface="+mn-lt"/>
+                <a:ea typeface="+mn-ea"/>
+                <a:cs typeface="+mn-cs"/>
+              </a:defRPr>
+            </a:lvl4pPr>
+            <a:lvl5pPr marL="1828800" algn="l" defTabSz="914400" rtl="0" eaLnBrk="1" latinLnBrk="0" hangingPunct="1">
+              <a:defRPr sz="1800" kern="1200">
+                <a:solidFill>
+                  <a:schemeClr val="lt1"/>
+                </a:solidFill>
+                <a:latin typeface="+mn-lt"/>
+                <a:ea typeface="+mn-ea"/>
+                <a:cs typeface="+mn-cs"/>
+              </a:defRPr>
+            </a:lvl5pPr>
+            <a:lvl6pPr marL="2286000" algn="l" defTabSz="914400" rtl="0" eaLnBrk="1" latinLnBrk="0" hangingPunct="1">
+              <a:defRPr sz="1800" kern="1200">
+                <a:solidFill>
+                  <a:schemeClr val="lt1"/>
+                </a:solidFill>
+                <a:latin typeface="+mn-lt"/>
+                <a:ea typeface="+mn-ea"/>
+                <a:cs typeface="+mn-cs"/>
+              </a:defRPr>
+            </a:lvl6pPr>
+            <a:lvl7pPr marL="2743200" algn="l" defTabSz="914400" rtl="0" eaLnBrk="1" latinLnBrk="0" hangingPunct="1">
+              <a:defRPr sz="1800" kern="1200">
+                <a:solidFill>
+                  <a:schemeClr val="lt1"/>
+                </a:solidFill>
+                <a:latin typeface="+mn-lt"/>
+                <a:ea typeface="+mn-ea"/>
+                <a:cs typeface="+mn-cs"/>
+              </a:defRPr>
+            </a:lvl7pPr>
+            <a:lvl8pPr marL="3200400" algn="l" defTabSz="914400" rtl="0" eaLnBrk="1" latinLnBrk="0" hangingPunct="1">
+              <a:defRPr sz="1800" kern="1200">
+                <a:solidFill>
+                  <a:schemeClr val="lt1"/>
+                </a:solidFill>
+                <a:latin typeface="+mn-lt"/>
+                <a:ea typeface="+mn-ea"/>
+                <a:cs typeface="+mn-cs"/>
+              </a:defRPr>
+            </a:lvl8pPr>
+            <a:lvl9pPr marL="3657600" algn="l" defTabSz="914400" rtl="0" eaLnBrk="1" latinLnBrk="0" hangingPunct="1">
+              <a:defRPr sz="1800" kern="1200">
+                <a:solidFill>
+                  <a:schemeClr val="lt1"/>
+                </a:solidFill>
+                <a:latin typeface="+mn-lt"/>
+                <a:ea typeface="+mn-ea"/>
+                <a:cs typeface="+mn-cs"/>
+              </a:defRPr>
+            </a:lvl9pPr>
+          </a:lstStyle>
+          <a:p>
+            <a:pPr algn="ctr"/>
+            <a:endParaRPr lang="en-US"/>
+          </a:p>
+        </p:txBody>
+      </p:sp>
+      <p:pic>
+        <p:nvPicPr>
+          <p:cNvPr id="5" name="Picture 4">
+            <a:extLst>
+              <a:ext uri="{FF2B5EF4-FFF2-40B4-BE49-F238E27FC236}">
+                <a16:creationId xmlns:a16="http://schemas.microsoft.com/office/drawing/2014/main" id="{9F46C17E-7ECF-FD09-D599-1D95C28E421F}"/>
+              </a:ext>
+            </a:extLst>
+          </p:cNvPr>
+          <p:cNvPicPr>
+            <a:picLocks noChangeAspect="1"/>
+          </p:cNvPicPr>
+          <p:nvPr/>
+        </p:nvPicPr>
+        <p:blipFill>
+          <a:blip r:embed="rId2">
+            <a:extLst>
+              <a:ext uri="{28A0092B-C50C-407E-A947-70E740481C1C}">
+                <a14:useLocalDpi xmlns:a14="http://schemas.microsoft.com/office/drawing/2010/main" val="0"/>
+              </a:ext>
+            </a:extLst>
+          </a:blip>
+          <a:srcRect t="15429"/>
+          <a:stretch>
+            <a:fillRect/>
+          </a:stretch>
+        </p:blipFill>
+        <p:spPr>
+          <a:xfrm>
+            <a:off x="20" y="1282"/>
+            <a:ext cx="12191980" cy="6856718"/>
+          </a:xfrm>
+          <a:prstGeom prst="rect">
+            <a:avLst/>
+          </a:prstGeom>
+        </p:spPr>
+      </p:pic>
+      <p:sp>
+        <p:nvSpPr>
+          <p:cNvPr id="6" name="Rectangle 5">
+            <a:extLst>
+              <a:ext uri="{FF2B5EF4-FFF2-40B4-BE49-F238E27FC236}">
+                <a16:creationId xmlns:a16="http://schemas.microsoft.com/office/drawing/2014/main" id="{92A4816A-D166-0607-8BC3-D8956DC0C4F5}"/>
+              </a:ext>
+            </a:extLst>
+          </p:cNvPr>
+          <p:cNvSpPr/>
+          <p:nvPr/>
+        </p:nvSpPr>
+        <p:spPr>
+          <a:xfrm>
+            <a:off x="0" y="1"/>
+            <a:ext cx="7815159" cy="6858000"/>
+          </a:xfrm>
+          <a:prstGeom prst="rect">
+            <a:avLst/>
+          </a:prstGeom>
+          <a:gradFill flip="none" rotWithShape="1">
+            <a:gsLst>
+              <a:gs pos="0">
+                <a:schemeClr val="bg1"/>
+              </a:gs>
+              <a:gs pos="58000">
+                <a:schemeClr val="bg1">
+                  <a:alpha val="30000"/>
+                </a:schemeClr>
+              </a:gs>
+              <a:gs pos="100000">
+                <a:schemeClr val="bg1">
+                  <a:alpha val="0"/>
+                </a:schemeClr>
+              </a:gs>
+            </a:gsLst>
+            <a:lin ang="21594000" scaled="0"/>
+            <a:tileRect/>
+          </a:gradFill>
+          <a:ln>
+            <a:noFill/>
+          </a:ln>
+        </p:spPr>
+        <p:style>
+          <a:lnRef idx="2">
+            <a:schemeClr val="accent1">
+              <a:shade val="15000"/>
+            </a:schemeClr>
+          </a:lnRef>
+          <a:fillRef idx="1">
+            <a:schemeClr val="accent1"/>
+          </a:fillRef>
+          <a:effectRef idx="0">
+            <a:schemeClr val="accent1"/>
+          </a:effectRef>
+          <a:fontRef idx="minor">
+            <a:schemeClr val="lt1"/>
+          </a:fontRef>
+        </p:style>
+        <p:txBody>
+          <a:bodyPr rtlCol="0" anchor="ctr"/>
+          <a:lstStyle/>
+          <a:p>
+            <a:pPr algn="ctr"/>
+            <a:endParaRPr lang="en-US"/>
+          </a:p>
+        </p:txBody>
+      </p:sp>
+    </p:spTree>
+    <p:extLst>
+      <p:ext uri="{BB962C8B-B14F-4D97-AF65-F5344CB8AC3E}">
+        <p14:creationId xmlns:p14="http://schemas.microsoft.com/office/powerpoint/2010/main" val="1126054355"/>
+      </p:ext>
+    </p:extLst>
+  </p:cSld>
+  <p:clrMapOvr>
+    <a:masterClrMapping/>
+  </p:clrMapOvr>
+</p:sld>
+</file>
+
 <file path=ppt/theme/theme1.xml><?xml version="1.0" encoding="utf-8"?>
 <a:theme xmlns:a="http://schemas.openxmlformats.org/drawingml/2006/main" name="Office Theme">
   <a:themeElements>

</xml_diff>

<commit_message>
maintain one hero section bg image
</commit_message>
<xml_diff>
--- a/images/project image reshaper.pptx
+++ b/images/project image reshaper.pptx
@@ -11,7 +11,6 @@
     <p:sldId id="258" r:id="rId5"/>
     <p:sldId id="259" r:id="rId6"/>
     <p:sldId id="260" r:id="rId7"/>
-    <p:sldId id="263" r:id="rId8"/>
   </p:sldIdLst>
   <p:sldSz cx="12192000" cy="6858000"/>
   <p:notesSz cx="6858000" cy="9144000"/>
@@ -4471,304 +4470,6 @@
 </p:sld>
 </file>
 
-<file path=ppt/slides/slide7.xml><?xml version="1.0" encoding="utf-8"?>
-<p:sld xmlns:a="http://schemas.openxmlformats.org/drawingml/2006/main" xmlns:r="http://schemas.openxmlformats.org/officeDocument/2006/relationships" xmlns:p="http://schemas.openxmlformats.org/presentationml/2006/main">
-  <p:cSld>
-    <p:bg>
-      <p:bgPr>
-        <a:solidFill>
-          <a:schemeClr val="bg1"/>
-        </a:solidFill>
-        <a:effectLst/>
-      </p:bgPr>
-    </p:bg>
-    <p:spTree>
-      <p:nvGrpSpPr>
-        <p:cNvPr id="1" name=""/>
-        <p:cNvGrpSpPr/>
-        <p:nvPr/>
-      </p:nvGrpSpPr>
-      <p:grpSpPr>
-        <a:xfrm>
-          <a:off x="0" y="0"/>
-          <a:ext cx="0" cy="0"/>
-          <a:chOff x="0" y="0"/>
-          <a:chExt cx="0" cy="0"/>
-        </a:xfrm>
-      </p:grpSpPr>
-      <p:sp>
-        <p:nvSpPr>
-          <p:cNvPr id="10" name="Rectangle 9">
-            <a:extLst>
-              <a:ext uri="{FF2B5EF4-FFF2-40B4-BE49-F238E27FC236}">
-                <a16:creationId xmlns:a16="http://schemas.microsoft.com/office/drawing/2014/main" id="{42A4FC2C-047E-45A5-965D-8E1E3BF09BC6}"/>
-              </a:ext>
-              <a:ext uri="{C183D7F6-B498-43B3-948B-1728B52AA6E4}">
-                <adec:decorative xmlns:adec="http://schemas.microsoft.com/office/drawing/2017/decorative" val="1"/>
-              </a:ext>
-            </a:extLst>
-          </p:cNvPr>
-          <p:cNvSpPr>
-            <a:spLocks noGrp="1" noRot="1" noChangeAspect="1" noMove="1" noResize="1" noEditPoints="1" noAdjustHandles="1" noChangeArrowheads="1" noChangeShapeType="1" noTextEdit="1"/>
-          </p:cNvSpPr>
-          <p:nvPr>
-            <p:extLst>
-              <p:ext uri="{386F3935-93C4-4BCD-93E2-E3B085C9AB24}">
-                <p16:designElem xmlns:p16="http://schemas.microsoft.com/office/powerpoint/2015/main" val="1"/>
-              </p:ext>
-            </p:extLst>
-          </p:nvPr>
-        </p:nvSpPr>
-        <p:spPr bwMode="white">
-          <a:xfrm>
-            <a:off x="1524" y="0"/>
-            <a:ext cx="12188952" cy="6858000"/>
-          </a:xfrm>
-          <a:prstGeom prst="rect">
-            <a:avLst/>
-          </a:prstGeom>
-          <a:noFill/>
-          <a:ln>
-            <a:noFill/>
-          </a:ln>
-        </p:spPr>
-        <p:style>
-          <a:lnRef idx="2">
-            <a:schemeClr val="accent1">
-              <a:shade val="50000"/>
-            </a:schemeClr>
-          </a:lnRef>
-          <a:fillRef idx="1">
-            <a:schemeClr val="accent1"/>
-          </a:fillRef>
-          <a:effectRef idx="0">
-            <a:schemeClr val="accent1"/>
-          </a:effectRef>
-          <a:fontRef idx="minor">
-            <a:schemeClr val="lt1"/>
-          </a:fontRef>
-        </p:style>
-        <p:txBody>
-          <a:bodyPr rtlCol="0" anchor="ctr"/>
-          <a:lstStyle>
-            <a:defPPr>
-              <a:defRPr lang="en-US"/>
-            </a:defPPr>
-            <a:lvl1pPr marL="0" algn="l" defTabSz="914400" rtl="0" eaLnBrk="1" latinLnBrk="0" hangingPunct="1">
-              <a:defRPr sz="1800" kern="1200">
-                <a:solidFill>
-                  <a:schemeClr val="lt1"/>
-                </a:solidFill>
-                <a:latin typeface="+mn-lt"/>
-                <a:ea typeface="+mn-ea"/>
-                <a:cs typeface="+mn-cs"/>
-              </a:defRPr>
-            </a:lvl1pPr>
-            <a:lvl2pPr marL="457200" algn="l" defTabSz="914400" rtl="0" eaLnBrk="1" latinLnBrk="0" hangingPunct="1">
-              <a:defRPr sz="1800" kern="1200">
-                <a:solidFill>
-                  <a:schemeClr val="lt1"/>
-                </a:solidFill>
-                <a:latin typeface="+mn-lt"/>
-                <a:ea typeface="+mn-ea"/>
-                <a:cs typeface="+mn-cs"/>
-              </a:defRPr>
-            </a:lvl2pPr>
-            <a:lvl3pPr marL="914400" algn="l" defTabSz="914400" rtl="0" eaLnBrk="1" latinLnBrk="0" hangingPunct="1">
-              <a:defRPr sz="1800" kern="1200">
-                <a:solidFill>
-                  <a:schemeClr val="lt1"/>
-                </a:solidFill>
-                <a:latin typeface="+mn-lt"/>
-                <a:ea typeface="+mn-ea"/>
-                <a:cs typeface="+mn-cs"/>
-              </a:defRPr>
-            </a:lvl3pPr>
-            <a:lvl4pPr marL="1371600" algn="l" defTabSz="914400" rtl="0" eaLnBrk="1" latinLnBrk="0" hangingPunct="1">
-              <a:defRPr sz="1800" kern="1200">
-                <a:solidFill>
-                  <a:schemeClr val="lt1"/>
-                </a:solidFill>
-                <a:latin typeface="+mn-lt"/>
-                <a:ea typeface="+mn-ea"/>
-                <a:cs typeface="+mn-cs"/>
-              </a:defRPr>
-            </a:lvl4pPr>
-            <a:lvl5pPr marL="1828800" algn="l" defTabSz="914400" rtl="0" eaLnBrk="1" latinLnBrk="0" hangingPunct="1">
-              <a:defRPr sz="1800" kern="1200">
-                <a:solidFill>
-                  <a:schemeClr val="lt1"/>
-                </a:solidFill>
-                <a:latin typeface="+mn-lt"/>
-                <a:ea typeface="+mn-ea"/>
-                <a:cs typeface="+mn-cs"/>
-              </a:defRPr>
-            </a:lvl5pPr>
-            <a:lvl6pPr marL="2286000" algn="l" defTabSz="914400" rtl="0" eaLnBrk="1" latinLnBrk="0" hangingPunct="1">
-              <a:defRPr sz="1800" kern="1200">
-                <a:solidFill>
-                  <a:schemeClr val="lt1"/>
-                </a:solidFill>
-                <a:latin typeface="+mn-lt"/>
-                <a:ea typeface="+mn-ea"/>
-                <a:cs typeface="+mn-cs"/>
-              </a:defRPr>
-            </a:lvl6pPr>
-            <a:lvl7pPr marL="2743200" algn="l" defTabSz="914400" rtl="0" eaLnBrk="1" latinLnBrk="0" hangingPunct="1">
-              <a:defRPr sz="1800" kern="1200">
-                <a:solidFill>
-                  <a:schemeClr val="lt1"/>
-                </a:solidFill>
-                <a:latin typeface="+mn-lt"/>
-                <a:ea typeface="+mn-ea"/>
-                <a:cs typeface="+mn-cs"/>
-              </a:defRPr>
-            </a:lvl7pPr>
-            <a:lvl8pPr marL="3200400" algn="l" defTabSz="914400" rtl="0" eaLnBrk="1" latinLnBrk="0" hangingPunct="1">
-              <a:defRPr sz="1800" kern="1200">
-                <a:solidFill>
-                  <a:schemeClr val="lt1"/>
-                </a:solidFill>
-                <a:latin typeface="+mn-lt"/>
-                <a:ea typeface="+mn-ea"/>
-                <a:cs typeface="+mn-cs"/>
-              </a:defRPr>
-            </a:lvl8pPr>
-            <a:lvl9pPr marL="3657600" algn="l" defTabSz="914400" rtl="0" eaLnBrk="1" latinLnBrk="0" hangingPunct="1">
-              <a:defRPr sz="1800" kern="1200">
-                <a:solidFill>
-                  <a:schemeClr val="lt1"/>
-                </a:solidFill>
-                <a:latin typeface="+mn-lt"/>
-                <a:ea typeface="+mn-ea"/>
-                <a:cs typeface="+mn-cs"/>
-              </a:defRPr>
-            </a:lvl9pPr>
-          </a:lstStyle>
-          <a:p>
-            <a:pPr algn="ctr"/>
-            <a:endParaRPr lang="en-US"/>
-          </a:p>
-        </p:txBody>
-      </p:sp>
-      <p:pic>
-        <p:nvPicPr>
-          <p:cNvPr id="5" name="Picture 4">
-            <a:extLst>
-              <a:ext uri="{FF2B5EF4-FFF2-40B4-BE49-F238E27FC236}">
-                <a16:creationId xmlns:a16="http://schemas.microsoft.com/office/drawing/2014/main" id="{9F46C17E-7ECF-FD09-D599-1D95C28E421F}"/>
-              </a:ext>
-            </a:extLst>
-          </p:cNvPr>
-          <p:cNvPicPr>
-            <a:picLocks noChangeAspect="1"/>
-          </p:cNvPicPr>
-          <p:nvPr/>
-        </p:nvPicPr>
-        <p:blipFill>
-          <a:blip r:embed="rId2">
-            <a:extLst>
-              <a:ext uri="{28A0092B-C50C-407E-A947-70E740481C1C}">
-                <a14:useLocalDpi xmlns:a14="http://schemas.microsoft.com/office/drawing/2010/main" val="0"/>
-              </a:ext>
-            </a:extLst>
-          </a:blip>
-          <a:srcRect t="15429"/>
-          <a:stretch>
-            <a:fillRect/>
-          </a:stretch>
-        </p:blipFill>
-        <p:spPr>
-          <a:xfrm>
-            <a:off x="20" y="1282"/>
-            <a:ext cx="12191980" cy="6856718"/>
-          </a:xfrm>
-          <a:prstGeom prst="rect">
-            <a:avLst/>
-          </a:prstGeom>
-        </p:spPr>
-      </p:pic>
-      <p:sp>
-        <p:nvSpPr>
-          <p:cNvPr id="6" name="Rectangle 5">
-            <a:extLst>
-              <a:ext uri="{FF2B5EF4-FFF2-40B4-BE49-F238E27FC236}">
-                <a16:creationId xmlns:a16="http://schemas.microsoft.com/office/drawing/2014/main" id="{92A4816A-D166-0607-8BC3-D8956DC0C4F5}"/>
-              </a:ext>
-            </a:extLst>
-          </p:cNvPr>
-          <p:cNvSpPr/>
-          <p:nvPr/>
-        </p:nvSpPr>
-        <p:spPr>
-          <a:xfrm>
-            <a:off x="0" y="1"/>
-            <a:ext cx="7815159" cy="6858000"/>
-          </a:xfrm>
-          <a:prstGeom prst="rect">
-            <a:avLst/>
-          </a:prstGeom>
-          <a:gradFill flip="none" rotWithShape="1">
-            <a:gsLst>
-              <a:gs pos="0">
-                <a:schemeClr val="bg1"/>
-              </a:gs>
-              <a:gs pos="58000">
-                <a:schemeClr val="bg1">
-                  <a:alpha val="30000"/>
-                </a:schemeClr>
-              </a:gs>
-              <a:gs pos="100000">
-                <a:schemeClr val="bg1">
-                  <a:alpha val="0"/>
-                </a:schemeClr>
-              </a:gs>
-            </a:gsLst>
-            <a:lin ang="21594000" scaled="0"/>
-            <a:tileRect/>
-          </a:gradFill>
-          <a:ln>
-            <a:noFill/>
-          </a:ln>
-        </p:spPr>
-        <p:style>
-          <a:lnRef idx="2">
-            <a:schemeClr val="accent1">
-              <a:shade val="15000"/>
-            </a:schemeClr>
-          </a:lnRef>
-          <a:fillRef idx="1">
-            <a:schemeClr val="accent1"/>
-          </a:fillRef>
-          <a:effectRef idx="0">
-            <a:schemeClr val="accent1"/>
-          </a:effectRef>
-          <a:fontRef idx="minor">
-            <a:schemeClr val="lt1"/>
-          </a:fontRef>
-        </p:style>
-        <p:txBody>
-          <a:bodyPr rtlCol="0" anchor="ctr"/>
-          <a:lstStyle/>
-          <a:p>
-            <a:pPr algn="ctr"/>
-            <a:endParaRPr lang="en-US"/>
-          </a:p>
-        </p:txBody>
-      </p:sp>
-    </p:spTree>
-    <p:extLst>
-      <p:ext uri="{BB962C8B-B14F-4D97-AF65-F5344CB8AC3E}">
-        <p14:creationId xmlns:p14="http://schemas.microsoft.com/office/powerpoint/2010/main" val="1126054355"/>
-      </p:ext>
-    </p:extLst>
-  </p:cSld>
-  <p:clrMapOvr>
-    <a:masterClrMapping/>
-  </p:clrMapOvr>
-</p:sld>
-</file>
-
 <file path=ppt/theme/theme1.xml><?xml version="1.0" encoding="utf-8"?>
 <a:theme xmlns:a="http://schemas.openxmlformats.org/drawingml/2006/main" name="Office Theme">
   <a:themeElements>

</xml_diff>